<commit_message>
Update PPT and README
</commit_message>
<xml_diff>
--- a/FloodSafe_Sindh_OpenHack26.pptx
+++ b/FloodSafe_Sindh_OpenHack26.pptx
@@ -1808,7 +1808,7 @@
         <p:spPr>
           <a:xfrm>
             <a:off x="731520" y="1188720"/>
-            <a:ext cx="7680960" cy="1005840"/>
+            <a:ext cx="4937760" cy="1005840"/>
           </a:xfrm>
           <a:prstGeom prst="rect">
             <a:avLst/>
@@ -1817,48 +1817,48 @@
           <a:ln/>
         </p:spPr>
         <p:txBody>
+          <a:bodyPr wrap="none" lIns="0" tIns="0" rIns="0" bIns="0" rtlCol="0" anchor="t"/>
+          <a:lstStyle/>
+          <a:p>
+            <a:pPr indent="0" marL="0" algn="l">
+              <a:buNone/>
+            </a:pPr>
+            <a:r>
+              <a:rPr lang="en-US" sz="3800" b="1" dirty="0">
+                <a:solidFill>
+                  <a:schemeClr val="bg1"/>
+                </a:solidFill>
+              </a:rPr>
+              <a:t>FloodSafe Sindh</a:t>
+            </a:r>
+            <a:endParaRPr lang="en-US" sz="4800" dirty="0"/>
+          </a:p>
+        </p:txBody>
+      </p:sp>
+      <p:sp>
+        <p:nvSpPr>
+          <p:cNvPr id="3" name="Text 2"/>
+          <p:cNvSpPr/>
+          <p:nvPr>
+            <p:ph idx="103" type="body" hasCustomPrompt="1"/>
+          </p:nvPr>
+        </p:nvSpPr>
+        <p:spPr>
+          <a:xfrm>
+            <a:off x="731520" y="2286000"/>
+            <a:ext cx="4937760" cy="548640"/>
+          </a:xfrm>
+          <a:prstGeom prst="rect">
+            <a:avLst/>
+          </a:prstGeom>
+          <a:noFill/>
+          <a:ln/>
+        </p:spPr>
+        <p:txBody>
           <a:bodyPr wrap="square" lIns="0" tIns="0" rIns="0" bIns="0" rtlCol="0" anchor="t"/>
           <a:lstStyle/>
           <a:p>
-            <a:pPr indent="0" marL="0">
-              <a:buNone/>
-            </a:pPr>
-            <a:r>
-              <a:rPr lang="en-US" sz="4800" b="1" dirty="0">
-                <a:solidFill>
-                  <a:schemeClr val="bg1"/>
-                </a:solidFill>
-              </a:rPr>
-              <a:t>FloodSafe Sindh</a:t>
-            </a:r>
-            <a:endParaRPr lang="en-US" sz="4800" dirty="0"/>
-          </a:p>
-        </p:txBody>
-      </p:sp>
-      <p:sp>
-        <p:nvSpPr>
-          <p:cNvPr id="3" name="Text 2"/>
-          <p:cNvSpPr/>
-          <p:nvPr>
-            <p:ph idx="103" type="body" hasCustomPrompt="1"/>
-          </p:nvPr>
-        </p:nvSpPr>
-        <p:spPr>
-          <a:xfrm>
-            <a:off x="731520" y="2286000"/>
-            <a:ext cx="7680960" cy="548640"/>
-          </a:xfrm>
-          <a:prstGeom prst="rect">
-            <a:avLst/>
-          </a:prstGeom>
-          <a:noFill/>
-          <a:ln/>
-        </p:spPr>
-        <p:txBody>
-          <a:bodyPr wrap="square" lIns="0" tIns="0" rIns="0" bIns="0" rtlCol="0" anchor="t"/>
-          <a:lstStyle/>
-          <a:p>
-            <a:pPr indent="0" marL="0">
+            <a:pPr indent="0" marL="0" algn="l">
               <a:buNone/>
             </a:pPr>
             <a:r>
@@ -1882,7 +1882,7 @@
         <p:spPr>
           <a:xfrm>
             <a:off x="731520" y="3200400"/>
-            <a:ext cx="7680960" cy="365760"/>
+            <a:ext cx="4937760" cy="365760"/>
           </a:xfrm>
           <a:prstGeom prst="rect">
             <a:avLst/>
@@ -1894,7 +1894,7 @@
           <a:bodyPr wrap="square" lIns="0" tIns="0" rIns="0" bIns="0" rtlCol="0" anchor="ctr"/>
           <a:lstStyle/>
           <a:p>
-            <a:pPr indent="0" marL="0">
+            <a:pPr indent="0" marL="0" algn="l">
               <a:buNone/>
             </a:pPr>
             <a:r>
@@ -1918,7 +1918,7 @@
         <p:spPr>
           <a:xfrm>
             <a:off x="731520" y="3931920"/>
-            <a:ext cx="7680960" cy="365760"/>
+            <a:ext cx="4937760" cy="365760"/>
           </a:xfrm>
           <a:prstGeom prst="rect">
             <a:avLst/>
@@ -1930,7 +1930,7 @@
           <a:bodyPr wrap="square" lIns="0" tIns="0" rIns="0" bIns="0" rtlCol="0" anchor="ctr"/>
           <a:lstStyle/>
           <a:p>
-            <a:pPr indent="0" marL="0">
+            <a:pPr indent="0" marL="0" algn="l">
               <a:buNone/>
             </a:pPr>
             <a:r>
@@ -1939,12 +1939,36 @@
                   <a:schemeClr val="bg1"/>
                 </a:solidFill>
               </a:rPr>
-              <a:t>Team: [add registered team name]</a:t>
+              <a:t>Team ZEROX  |  Ali, Huzaifa</a:t>
             </a:r>
             <a:endParaRPr lang="en-US" sz="1600" dirty="0"/>
           </a:p>
         </p:txBody>
       </p:sp>
+      <p:pic>
+        <p:nvPicPr>
+          <p:cNvPr id="6" name="Picture 5" descr="Illustration: people worried on a flooded house roof in heavy rain, with worried face reactions"/>
+          <p:cNvPicPr>
+            <a:picLocks noChangeAspect="1"/>
+          </p:cNvPicPr>
+          <p:nvPr/>
+        </p:nvPicPr>
+        <p:blipFill>
+          <a:blip r:embed="rId3"/>
+          <a:stretch>
+            <a:fillRect/>
+          </a:stretch>
+        </p:blipFill>
+        <p:spPr>
+          <a:xfrm>
+            <a:off x="5852160" y="0"/>
+            <a:ext cx="3291840" cy="5143500"/>
+          </a:xfrm>
+          <a:prstGeom prst="rect">
+            <a:avLst/>
+          </a:prstGeom>
+        </p:spPr>
+      </p:pic>
     </p:spTree>
   </p:cSld>
   <p:clrMapOvr>
@@ -2285,6 +2309,102 @@
           </a:p>
         </p:txBody>
       </p:sp>
+      <p:pic>
+        <p:nvPicPr>
+          <p:cNvPr id="26" name="Picture 25" descr="Illustration: worried people standing in rising flood water during heavy rain"/>
+          <p:cNvPicPr>
+            <a:picLocks noChangeAspect="1"/>
+          </p:cNvPicPr>
+          <p:nvPr/>
+        </p:nvPicPr>
+        <p:blipFill>
+          <a:blip r:embed="rId3"/>
+          <a:stretch>
+            <a:fillRect/>
+          </a:stretch>
+        </p:blipFill>
+        <p:spPr>
+          <a:xfrm>
+            <a:off x="548640" y="3566160"/>
+            <a:ext cx="4297680" cy="1193840"/>
+          </a:xfrm>
+          <a:prstGeom prst="rect">
+            <a:avLst/>
+          </a:prstGeom>
+        </p:spPr>
+      </p:pic>
+      <p:pic>
+        <p:nvPicPr>
+          <p:cNvPr id="27" name="Picture 26" descr="fearful face reaction"/>
+          <p:cNvPicPr>
+            <a:picLocks noChangeAspect="1"/>
+          </p:cNvPicPr>
+          <p:nvPr/>
+        </p:nvPicPr>
+        <p:blipFill>
+          <a:blip r:embed="rId4"/>
+          <a:stretch>
+            <a:fillRect/>
+          </a:stretch>
+        </p:blipFill>
+        <p:spPr>
+          <a:xfrm>
+            <a:off x="8165592" y="1783080"/>
+            <a:ext cx="411480" cy="411480"/>
+          </a:xfrm>
+          <a:prstGeom prst="rect">
+            <a:avLst/>
+          </a:prstGeom>
+        </p:spPr>
+      </p:pic>
+      <p:pic>
+        <p:nvPicPr>
+          <p:cNvPr id="28" name="Picture 27" descr="worried face reaction"/>
+          <p:cNvPicPr>
+            <a:picLocks noChangeAspect="1"/>
+          </p:cNvPicPr>
+          <p:nvPr/>
+        </p:nvPicPr>
+        <p:blipFill>
+          <a:blip r:embed="rId5"/>
+          <a:stretch>
+            <a:fillRect/>
+          </a:stretch>
+        </p:blipFill>
+        <p:spPr>
+          <a:xfrm>
+            <a:off x="8165592" y="2834640"/>
+            <a:ext cx="411480" cy="411480"/>
+          </a:xfrm>
+          <a:prstGeom prst="rect">
+            <a:avLst/>
+          </a:prstGeom>
+        </p:spPr>
+      </p:pic>
+      <p:pic>
+        <p:nvPicPr>
+          <p:cNvPr id="29" name="Picture 28" descr="sad face reaction"/>
+          <p:cNvPicPr>
+            <a:picLocks noChangeAspect="1"/>
+          </p:cNvPicPr>
+          <p:nvPr/>
+        </p:nvPicPr>
+        <p:blipFill>
+          <a:blip r:embed="rId6"/>
+          <a:stretch>
+            <a:fillRect/>
+          </a:stretch>
+        </p:blipFill>
+        <p:spPr>
+          <a:xfrm>
+            <a:off x="8165592" y="3886200"/>
+            <a:ext cx="411480" cy="411480"/>
+          </a:xfrm>
+          <a:prstGeom prst="rect">
+            <a:avLst/>
+          </a:prstGeom>
+        </p:spPr>
+      </p:pic>
     </p:spTree>
   </p:cSld>
   <p:clrMapOvr>
@@ -3831,7 +3951,7 @@
                   <a:schemeClr val="bg1"/>
                 </a:solidFill>
               </a:rPr>
-              <a:t>Team: [add names and contributions]</a:t>
+              <a:t>Team ZEROX  |  Members: Ali, Huzaifa</a:t>
             </a:r>
             <a:endParaRPr lang="en-US" sz="1500" dirty="0"/>
           </a:p>

</xml_diff>